<commit_message>
Consolidate overview research and relocate example evaluations
Bind all overview formats to one canonical research snapshot, regenerate affected artifacts and receipts, and move shared example QA into evals/examples with updated references.

Co-authored-by: Copilot App <223556219+Copilot@users.noreply.github.com>
</commit_message>
<xml_diff>
--- a/examples/project-overview/overview.pptx
+++ b/examples/project-overview/overview.pptx
@@ -511,7 +511,7 @@
             <a:r>
               <a:rPr lang="en-US" dirty="0"/>
               <a:t>slide-01-purpose
-Aha combines two portable Skills and a local runtime. The host Agent performs investigation and content design. Shared factual grounding does not imply shared layouts or automatic all-format generation. The diagram shows reuse of research, not a one-click conversion pipeline.,Research scope: fixed repository commit a013ea795312eab9ae2e4224998a1314eea8f718; reviewed 2026-09-15. Runtime 0.3.0; research/artifact protocol 1.0.0.,Bound Research Dossier: b547322594e90fb21a9aad36c40b7658cfe6c73d591e69481d95fdc20408a3bf. This deck translates the supported conclusions into English; it does not alter the research snapshot.,Fixed repository references:
+Aha combines two portable Skills and a local runtime. The host Agent performs investigation and content design. Shared factual grounding does not imply shared layouts or automatic all-format generation. The diagram shows reuse of research, not a one-click conversion pipeline.,Research scope: fixed repository commit a013ea795312eab9ae2e4224998a1314eea8f718; reviewed 2026-09-15. Runtime 0.3.0; research/artifact protocol 1.0.0.,Bound Research Dossier: aha-project-overview-examples-20260915. The companion render receipt records its content hash. This deck translates the supported conclusions into English; it does not alter the research snapshot.,Fixed repository references:
 https://github.com/sawyer0x110/aha/blob/a013ea795312eab9ae2e4224998a1314eea8f718/README.md#L1-L39
 https://github.com/sawyer0x110/aha/blob/a013ea795312eab9ae2e4224998a1314eea8f718/docs/ARCHITECTURE.md#L1-L136</a:t>
             </a:r>
@@ -602,7 +602,7 @@
             <a:r>
               <a:rPr lang="en-US" dirty="0"/>
               <a:t>slide-02-responsibilities
-The two Skills share research guidance; aha-explain does not depend on the host automatically dispatching a task to aha-research. Reports can be complete deliverables without slides. Structural checks are not source-support review or evidence of host discovery.,Research scope: fixed repository commit a013ea795312eab9ae2e4224998a1314eea8f718; reviewed 2026-09-15. Runtime 0.3.0; research/artifact protocol 1.0.0.,Bound Research Dossier: b547322594e90fb21a9aad36c40b7658cfe6c73d591e69481d95fdc20408a3bf. This deck translates the supported conclusions into English; it does not alter the research snapshot.,Fixed repository references:
+The two Skills share research guidance; aha-explain does not depend on the host automatically dispatching a task to aha-research. Reports can be complete deliverables without slides. Structural checks are not source-support review or evidence of host discovery.,Research scope: fixed repository commit a013ea795312eab9ae2e4224998a1314eea8f718; reviewed 2026-09-15. Runtime 0.3.0; research/artifact protocol 1.0.0.,Bound Research Dossier: aha-project-overview-examples-20260915. The companion render receipt records its content hash. This deck translates the supported conclusions into English; it does not alter the research snapshot.,Fixed repository references:
 https://github.com/sawyer0x110/aha/blob/a013ea795312eab9ae2e4224998a1314eea8f718/skills/aha-research/SKILL.md#L1-L23
 https://github.com/sawyer0x110/aha/blob/a013ea795312eab9ae2e4224998a1314eea8f718/skills/aha-explain/SKILL.md#L1-L22
 https://github.com/sawyer0x110/aha/blob/a013ea795312eab9ae2e4224998a1314eea8f718/README.md#L31-L39</a:t>
@@ -694,7 +694,7 @@
             <a:r>
               <a:rPr lang="en-US" dirty="0"/>
               <a:t>slide-03-identity
-Research Dossier files store the independent report and its content identity. Artifact metadata declares one format, entry, language, dimensions, researchHash, coverage and omissions. Every claim must be covered or explicitly omitted. The coverage map is an author declaration, not semantic proof. Hashes detect identity changes, not truth. HTML/PNG/PPTX receipts and the separate video chain should not be conflated. Research changes require a new snapshot and deliberate rebinding.,Research scope: fixed repository commit a013ea795312eab9ae2e4224998a1314eea8f718; reviewed 2026-09-15. Runtime 0.3.0; research/artifact protocol 1.0.0.,Bound Research Dossier: b547322594e90fb21a9aad36c40b7658cfe6c73d591e69481d95fdc20408a3bf. This deck translates the supported conclusions into English; it does not alter the research snapshot.,Fixed repository references:
+Research Dossier files store the independent report and its content identity. Artifact metadata declares one format, entry, language, dimensions, researchHash, coverage and omissions. Every claim must be covered or explicitly omitted. The coverage map is an author declaration, not semantic proof. Hashes detect identity changes, not truth. HTML/PNG/PPTX receipts and the separate video chain should not be conflated. Research changes require a new snapshot and deliberate rebinding.,Research scope: fixed repository commit a013ea795312eab9ae2e4224998a1314eea8f718; reviewed 2026-09-15. Runtime 0.3.0; research/artifact protocol 1.0.0.,Bound Research Dossier: aha-project-overview-examples-20260915. The companion render receipt records its content hash. This deck translates the supported conclusions into English; it does not alter the research snapshot.,Fixed repository references:
 https://github.com/sawyer0x110/aha/blob/a013ea795312eab9ae2e4224998a1314eea8f718/src/research/dossier.ts#L183-L225
 https://github.com/sawyer0x110/aha/blob/a013ea795312eab9ae2e4224998a1314eea8f718/src/artifacts/project.ts#L90-L168
 https://github.com/sawyer0x110/aha/blob/a013ea795312eab9ae2e4224998a1314eea8f718/src/artifacts/render.ts#L39-L81
@@ -788,7 +788,7 @@
             <a:r>
               <a:rPr lang="en-US" dirty="0"/>
               <a:t>slide-04-media
-The four rows compare authoring approaches, not measured performance or guaranteed outcomes. HTML supports bundled local assets and offline interactions. PNG must be composed for the intended dimensions. PPTX uses the supplied PptxGenJS instance and native objects. Video is an authored deterministic frame callback; actual audio duration drives frames and captions, with burned subtitles and SRT. Multiple formats require separately authored projects; there is no auto/all command.,Research scope: fixed repository commit a013ea795312eab9ae2e4224998a1314eea8f718; reviewed 2026-09-15. Runtime 0.3.0; research/artifact protocol 1.0.0.,Bound Research Dossier: b547322594e90fb21a9aad36c40b7658cfe6c73d591e69481d95fdc20408a3bf. This deck translates the supported conclusions into English; it does not alter the research snapshot.,Fixed repository references:
+The four rows compare authoring approaches, not measured performance or guaranteed outcomes. HTML supports bundled local assets and offline interactions. PNG must be composed for the intended dimensions. PPTX uses the supplied PptxGenJS instance and native objects. Video is an authored deterministic frame callback; actual audio duration drives frames and captions, with burned subtitles and SRT. Multiple formats require separately authored projects; there is no auto/all command.,Research scope: fixed repository commit a013ea795312eab9ae2e4224998a1314eea8f718; reviewed 2026-09-15. Runtime 0.3.0; research/artifact protocol 1.0.0.,Bound Research Dossier: aha-project-overview-examples-20260915. The companion render receipt records its content hash. This deck translates the supported conclusions into English; it does not alter the research snapshot.,Fixed repository references:
 https://github.com/sawyer0x110/aha/blob/a013ea795312eab9ae2e4224998a1314eea8f718/README.md#L23-L39
 https://github.com/sawyer0x110/aha/blob/a013ea795312eab9ae2e4224998a1314eea8f718/docs/ARCHITECTURE.md#L1-L136
 https://github.com/sawyer0x110/aha/blob/a013ea795312eab9ae2e4224998a1314eea8f718/src/artifacts/project.ts#L90-L168</a:t>
@@ -880,7 +880,7 @@
             <a:r>
               <a:rPr lang="en-US" dirty="0"/>
               <a:t>slide-demo-static
-The image on the left is a capture of the actual delivered HTML format-selector section. Its controls are interactive in the HTML, not in this screenshot. The right-hand thumbnail is the actual separately authored poster. It is intentionally a thumbnail and is not presented as readable full-size poster text. The current slide remains native editable text plus supporting raster previews. These example-specific observations are production evidence, not additional general claims about Aha.,Research scope: fixed repository commit a013ea795312eab9ae2e4224998a1314eea8f718; reviewed 2026-09-15. Runtime 0.3.0; research/artifact protocol 1.0.0.,Bound Research Dossier: b547322594e90fb21a9aad36c40b7658cfe6c73d591e69481d95fdc20408a3bf. This deck translates the supported conclusions into English; it does not alter the research snapshot.,Fixed repository references:
+The image on the left is a capture of the actual delivered HTML format-selector section. Its controls are interactive in the HTML, not in this screenshot. The right-hand thumbnail is the actual separately authored poster. It is intentionally a thumbnail and is not presented as readable full-size poster text. The current slide remains native editable text plus supporting raster previews. These example-specific observations are production evidence, not additional general claims about Aha.,Research scope: fixed repository commit a013ea795312eab9ae2e4224998a1314eea8f718; reviewed 2026-09-15. Runtime 0.3.0; research/artifact protocol 1.0.0.,Bound Research Dossier: aha-project-overview-examples-20260915. The companion render receipt records its content hash. This deck translates the supported conclusions into English; it does not alter the research snapshot.,Fixed repository references:
 https://github.com/sawyer0x110/aha/blob/a013ea795312eab9ae2e4224998a1314eea8f718/src/artifacts/project.ts#L90-L168
 https://github.com/sawyer0x110/aha/blob/a013ea795312eab9ae2e4224998a1314eea8f718/docs/ARCHITECTURE.md#L51-L89</a:t>
             </a:r>
@@ -971,7 +971,7 @@
             <a:r>
               <a:rPr lang="en-US" dirty="0"/>
               <a:t>slide-demo-motion
-PptxGenJS does not expose a native animation/transition API in this locked version. This example therefore embeds a genuine multi-frame GIF as a supporting animated image instead of inventing APIs, rewriting runtime receipts, or rasterizing the entire slide. Native headings and explanatory text remain editable; the animated illustration is edited through its HTML video source and regenerated. The GIF replays source/receipt revision and exact-plan approval scenes. Its illustrative duration is 8 seconds at 15 fps, not real speech timing. Static renderers may display only a still frame; slideshow playback requires a compatible presentation app.,Research scope: fixed repository commit a013ea795312eab9ae2e4224998a1314eea8f718; reviewed 2026-09-15. Runtime 0.3.0; research/artifact protocol 1.0.0.,Bound Research Dossier: b547322594e90fb21a9aad36c40b7658cfe6c73d591e69481d95fdc20408a3bf. This deck translates the supported conclusions into English; it does not alter the research snapshot.,Fixed repository references:
+PptxGenJS does not expose a native animation/transition API in this locked version. This example therefore embeds a genuine multi-frame GIF as a supporting animated image instead of inventing APIs, rewriting runtime receipts, or rasterizing the entire slide. Native headings and explanatory text remain editable; the animated illustration is edited through its HTML video source and regenerated. The GIF replays source/receipt revision and exact-plan approval scenes. Its illustrative duration is 8 seconds at 15 fps, not real speech timing. Static renderers may display only a still frame; slideshow playback requires a compatible presentation app.,Research scope: fixed repository commit a013ea795312eab9ae2e4224998a1314eea8f718; reviewed 2026-09-15. Runtime 0.3.0; research/artifact protocol 1.0.0.,Bound Research Dossier: aha-project-overview-examples-20260915. The companion render receipt records its content hash. This deck translates the supported conclusions into English; it does not alter the research snapshot.,Fixed repository references:
 https://github.com/sawyer0x110/aha/blob/a013ea795312eab9ae2e4224998a1314eea8f718/src/artifacts/render.ts#L203-L251
 https://github.com/sawyer0x110/aha/blob/a013ea795312eab9ae2e4224998a1314eea8f718/src/media/plan.ts#L58-L101
 https://github.com/sawyer0x110/aha/blob/a013ea795312eab9ae2e4224998a1314eea8f718/skills/aha-explain/references/video.md</a:t>
@@ -1063,7 +1063,7 @@
             <a:r>
               <a:rPr lang="en-US" dirty="0"/>
               <a:t>slide-05-permissions
-Local --allow-code permission must follow review of the current code and capabilities. Browser request restrictions do not isolate arbitrary Node code. HTML packaging itself does not execute authored scripts. Online Edge TTS separately requires approval of the complete current narration plan, provider, voice, rate, disclosure scope, and exact planHash; external network authorization is also separate. Plan/source mismatches are rejected. Source or voice changes cannot be authorized by hand-editing a hash. This introduction reports the contract, not a successful live TTS run.,Research scope: fixed repository commit a013ea795312eab9ae2e4224998a1314eea8f718; reviewed 2026-09-15. Runtime 0.3.0; research/artifact protocol 1.0.0.,Bound Research Dossier: b547322594e90fb21a9aad36c40b7658cfe6c73d591e69481d95fdc20408a3bf. This deck translates the supported conclusions into English; it does not alter the research snapshot.,Fixed repository references:
+Local --allow-code permission must follow review of the current code and capabilities. Browser request restrictions do not isolate arbitrary Node code. HTML packaging itself does not execute authored scripts. Online Edge TTS separately requires approval of the complete current narration plan, provider, voice, rate, disclosure scope, and exact planHash; external network authorization is also separate. Plan/source mismatches are rejected. Source or voice changes cannot be authorized by hand-editing a hash. This introduction reports the contract, not a successful live TTS run.,Research scope: fixed repository commit a013ea795312eab9ae2e4224998a1314eea8f718; reviewed 2026-09-15. Runtime 0.3.0; research/artifact protocol 1.0.0.,Bound Research Dossier: aha-project-overview-examples-20260915. The companion render receipt records its content hash. This deck translates the supported conclusions into English; it does not alter the research snapshot.,Fixed repository references:
 https://github.com/sawyer0x110/aha/blob/a013ea795312eab9ae2e4224998a1314eea8f718/skills/shared/references/execution.md#L1-L41
 https://github.com/sawyer0x110/aha/blob/a013ea795312eab9ae2e4224998a1314eea8f718/src/artifacts/render.ts#L39-L81
 https://github.com/sawyer0x110/aha/blob/a013ea795312eab9ae2e4224998a1314eea8f718/src/media/plan.ts#L58-L101</a:t>
@@ -1155,7 +1155,7 @@
             <a:r>
               <a:rPr lang="en-US" dirty="0"/>
               <a:t>slide-06-language-distribution
-New HTML defaults to bilingual with English initially visible. PNG, PPTX and video default to English. Explicit Chinese selection changes the artifact language rather than the Dossier. The Agent must author and check translations; a local language switch does not call a translation service. Build output contains exactly aha-research and aha-explain Skill bundles with CLI, schemas, references, local runtime libraries and notices. Source skills folders are not complete installation packages. Browser, Python and FFmpeg are not bundled. Reading a build implementation does not prove a release, host discovery or installation acceptance.,Research scope: fixed repository commit a013ea795312eab9ae2e4224998a1314eea8f718; reviewed 2026-09-15. Runtime 0.3.0; research/artifact protocol 1.0.0.,Bound Research Dossier: b547322594e90fb21a9aad36c40b7658cfe6c73d591e69481d95fdc20408a3bf. This deck translates the supported conclusions into English; it does not alter the research snapshot.,Fixed repository references:
+New HTML defaults to bilingual with English initially visible. PNG, PPTX and video default to English. Explicit Chinese selection changes the artifact language rather than the Dossier. The Agent must author and check translations; a local language switch does not call a translation service. Build output contains exactly aha-research and aha-explain Skill bundles with CLI, schemas, references, local runtime libraries and notices. Source skills folders are not complete installation packages. Browser, Python and FFmpeg are not bundled. Reading a build implementation does not prove a release, host discovery or installation acceptance.,Research scope: fixed repository commit a013ea795312eab9ae2e4224998a1314eea8f718; reviewed 2026-09-15. Runtime 0.3.0; research/artifact protocol 1.0.0.,Bound Research Dossier: aha-project-overview-examples-20260915. The companion render receipt records its content hash. This deck translates the supported conclusions into English; it does not alter the research snapshot.,Fixed repository references:
 https://github.com/sawyer0x110/aha/blob/a013ea795312eab9ae2e4224998a1314eea8f718/skills/aha-explain/references/language.md#L1-L57
 https://github.com/sawyer0x110/aha/blob/a013ea795312eab9ae2e4224998a1314eea8f718/src/artifacts/project.ts#L90-L168
 https://github.com/sawyer0x110/aha/blob/a013ea795312eab9ae2e4224998a1314eea8f718/scripts/build.ts#L111-L149
@@ -1249,7 +1249,7 @@
             <a:r>
               <a:rPr lang="en-US" dirty="0"/>
               <a:t>slide-07-quality
-The five questions are separate acceptance layers, not measured results or a maturity score. Research support, explanatory clarity, visual/native-editing quality, runtime integrity and real-person comprehension cannot substitute for one another. A passing schema check or receipt does not certify meaning. No independent human comprehension study, live-host acceptance or cross-machine PowerPoint compatibility is asserted. This deck is authored source; actual rendering and slide/editing review are separate production tasks.,Research scope: fixed repository commit a013ea795312eab9ae2e4224998a1314eea8f718; reviewed 2026-09-15. Runtime 0.3.0; research/artifact protocol 1.0.0.,Bound Research Dossier: b547322594e90fb21a9aad36c40b7658cfe6c73d591e69481d95fdc20408a3bf. This deck translates the supported conclusions into English; it does not alter the research snapshot.,Fixed repository references:
+The five questions are separate acceptance layers, not measured results or a maturity score. Research support, explanatory clarity, visual/native-editing quality, runtime integrity and real-person comprehension cannot substitute for one another. A passing schema check or receipt does not certify meaning. No independent human comprehension study, live-host acceptance or cross-machine PowerPoint compatibility is asserted. This deck is authored source; actual rendering and slide/editing review are separate production tasks.,Research scope: fixed repository commit a013ea795312eab9ae2e4224998a1314eea8f718; reviewed 2026-09-15. Runtime 0.3.0; research/artifact protocol 1.0.0.,Bound Research Dossier: aha-project-overview-examples-20260915. The companion render receipt records its content hash. This deck translates the supported conclusions into English; it does not alter the research snapshot.,Fixed repository references:
 https://github.com/sawyer0x110/aha/blob/a013ea795312eab9ae2e4224998a1314eea8f718/docs/ARCHITECTURE.md#L1-L136
 https://github.com/sawyer0x110/aha/blob/a013ea795312eab9ae2e4224998a1314eea8f718/skills/aha-explain/SKILL.md#L1-L22
 https://github.com/sawyer0x110/aha/blob/a013ea795312eab9ae2e4224998a1314eea8f718/src/artifacts/render.ts#L39-L81</a:t>

</xml_diff>

<commit_message>
Fix script scheduling, audio timing and research integrity
Preserve native deferred script execution, compute exact audio frame budgets, reject invalid UTF-8, enforce explicit bidirectional claim coverage, protect all example bytes from checkout conversion, and correct the PPT illustration relationship with a regenerated artifact and receipt.

Co-authored-by: Copilot App <223556219+Copilot@users.noreply.github.com>
</commit_message>
<xml_diff>
--- a/examples/project-overview/overview.pptx
+++ b/examples/project-overview/overview.pptx
@@ -971,7 +971,7 @@
             <a:r>
               <a:rPr lang="en-US" dirty="0"/>
               <a:t>slide-demo-motion
-PptxGenJS does not expose a native animation/transition API in this locked version. This example therefore embeds a genuine multi-frame GIF as a supporting animated image instead of inventing APIs, rewriting runtime receipts, or rasterizing the entire slide. Native headings and explanatory text remain editable; the animated illustration is edited through its HTML video source and regenerated. The GIF replays source/receipt revision and exact-plan approval scenes. Its illustrative duration is 8 seconds at 15 fps, not real speech timing. Static renderers may display only a still frame; slideshow playback requires a compatible presentation app.,Research scope: fixed repository commit a013ea795312eab9ae2e4224998a1314eea8f718; reviewed 2026-09-15. Runtime 0.3.0; research/artifact protocol 1.0.0.,Bound Research Dossier: aha-project-overview-examples-20260915. The companion render receipt records its content hash. This deck translates the supported conclusions into English; it does not alter the research snapshot.,Fixed repository references:
+PptxGenJS does not expose a native animation/transition API in this locked version. This example therefore embeds a genuine multi-frame GIF as a supporting animated image instead of inventing APIs, rewriting runtime receipts, or rasterizing the entire slide. Native headings and explanatory text remain editable; the animated illustration is edited through projects/motion-preview and regenerated. The GIF replays source/receipt revision and exact-plan approval scenes. These are independent illustrations, not scenes from the final narrated ANC/Git video. Its illustrative duration is 8 seconds at 15 fps, not real speech timing. Static renderers may display only a still frame; slideshow playback requires a compatible presentation app.,Research scope: fixed repository commit a013ea795312eab9ae2e4224998a1314eea8f718; reviewed 2026-09-15. Runtime 0.3.0; research/artifact protocol 1.0.0.,Bound Research Dossier: aha-project-overview-examples-20260915. The companion render receipt records its content hash. This deck translates the supported conclusions into English; it does not alter the research snapshot.,Fixed repository references:
 https://github.com/sawyer0x110/aha/blob/a013ea795312eab9ae2e4224998a1314eea8f718/src/artifacts/render.ts#L203-L251
 https://github.com/sawyer0x110/aha/blob/a013ea795312eab9ae2e4224998a1314eea8f718/src/media/plan.ts#L58-L101
 https://github.com/sawyer0x110/aha/blob/a013ea795312eab9ae2e4224998a1314eea8f718/skills/aha-explain/references/video.md</a:t>
@@ -6390,7 +6390,7 @@
                 <a:ea typeface="Segoe UI" pitchFamily="34" charset="-122"/>
                 <a:cs typeface="Segoe UI" pitchFamily="34" charset="-120"/>
               </a:rPr>
-              <a:t>05  /  PPTX + VIDEO IN ACTION</a:t>
+              <a:t>05  /  PPTX: SILENT ILLUSTRATION</a:t>
             </a:r>
             <a:endParaRPr lang="en-US" sz="1100" dirty="0"/>
           </a:p>
@@ -6626,7 +6626,7 @@
                 <a:ea typeface="Segoe UI" pitchFamily="34" charset="-122"/>
                 <a:cs typeface="Segoe UI" pitchFamily="34" charset="-120"/>
               </a:rPr>
-              <a:t>Video source supplies both scenes. The final narrated video uses measured speech timing—not this silent preview’s four seconds per scene.</a:t>
+              <a:t>This loop illustrates source changes and approval. It is separate from the narrated ANC and Git walkthrough.</a:t>
             </a:r>
             <a:endParaRPr lang="en-US" sz="1700" dirty="0"/>
           </a:p>

</xml_diff>